<commit_message>
feat: finally glossary of key terms across all lectures
</commit_message>
<xml_diff>
--- a/Lectio — смысловой поиск по видеолекциям.pptx
+++ b/Lectio — смысловой поиск по видеолекциям.pptx
@@ -975,7 +975,7 @@
           <a:p>
             <a:r>
               <a:rPr lang="en-US" dirty="0"/>
-              <a:t>Конспект делает языковая модель: лекция обрабатывается по частям, потом части сводятся в общий конспект и оглавление — разделы и подразделы с таймкодами. Таймкоды мы «примагничиваем» к реальным началам фрагментов, чтобы клик по разделу попадал точно. Формулы рендерятся через KaTeX. Отдельно выделяются ключевые термины с определением и моментом, где их впервые объяснили. Если модель недоступна, лекция всё равно ищется и смотрится — конспект best effort.</a:t>
+              <a:t>Конспект делает языковая модель: лекция обрабатывается по частям, потом части сводятся в общий конспект и оглавление — разделы и подразделы с таймкодами. Таймкоды мы «примагничиваем» к реальным началам фрагментов, чтобы клик по разделу попадал точно. Формулы рендерятся через KaTeX. Отдельно выделяются ключевые термины с определением и моментом, где их впервые объяснили. Из терминов всех лекций собирается общая энциклопедия: страница «Термины», где каждое понятие — с определениями из всех лекций, где его объясняли, и ссылкой на момент. Она обновляется сама, как только у лекции появляется конспект. Если модель недоступна, лекция всё равно ищется и смотрится — конспект best effort.</a:t>
             </a:r>
             <a:endParaRPr lang="en-US" dirty="0"/>
           </a:p>
@@ -1591,7 +1591,7 @@
           <a:p>
             <a:r>
               <a:rPr lang="en-US" dirty="0"/>
-              <a:t>Алгоритмы. Первое: Whisper отдаёт таймкод каждого слова, из слов мы собираем короткие реплики — это точные субтитры. Второе: расшифровка режется на фрагменты около 40 секунд с перекрытием, многоязычная модель BGE-M3 превращает каждый в вектор смысла. Третье, главное: гибридный поиск. Векторный находит перефразировки, полнотекстовый с русской морфологией — точные термины, а результаты сливаются методом Reciprocal Rank Fusion, без ручного подбора весов. Четвёртое: конспект делается по частям — модель читает лекцию кусками и сводит в общий конспект с оглавлением, таймкоды разделов привязываются к реальным фрагментам. Весь стек открытый, языковая модель локальная.</a:t>
+              <a:t>Алгоритмы. Первое: Whisper отдаёт таймкод каждого слова, из слов мы собираем короткие реплики — это точные субтитры. Второе: расшифровка режется на фрагменты около 40 секунд с перекрытием, многоязычная модель BGE-M3 превращает каждый в вектор смысла. Третье, главное: гибридный поиск. Векторный находит перефразировки, полнотекстовый с русской морфологией — точные термины, а результаты сливаются методом Reciprocal Rank Fusion, без ручного подбора весов. Четвёртое: конспект делается по частям — модель читает лекцию кусками и сводит в общий конспект с оглавлением, таймкоды разделов привязываются к реальным фрагментам. Весь стек открытый, языковая модель локальная. Качество держим тестами: 55 автотестов на pytest, в основном интеграционные — они гоняют API, воркер и бота на настоящих Postgres с pgvector, Redis и MinIO, а не на заглушках; заменены только нейросети, чтобы тесты шли за секунды. Плюс линтер ruff и строгая проверка типов basedpyright на бэкенде, TypeScript на фронте.</a:t>
             </a:r>
             <a:endParaRPr lang="en-US" dirty="0"/>
           </a:p>
@@ -1679,7 +1679,7 @@
           <a:p>
             <a:r>
               <a:rPr lang="en-US" dirty="0"/>
-              <a:t>60 секунд, живой показ строго по пунктам ТЗ, слева их порядок. 1 — в «Загрузить» → «Ссылка» вставить короткую ссылку youtu.be на лекцию, которая уже есть в библиотеке: Lectio узнаёт то же видео в любой форме ссылки и предлагает открыть готовую вместо повторной обработки — нажать «Открыть лекцию». Новую ссылку не импортировать: скачивание с YouTube зависит от сети, на защите оно может зависнуть. 2 — открыть готовую лекцию, вкладка «Расшифровка»: текст с таймкодами. 3 — поиск в шапке, запрос «как учиться с помощью нейросетей»: первой находится английская лекция; кликнуть результат — видео открывается на этой секунде. 4 — в плеере субтитры поверх видео; кликнуть реплику в «Сейчас говорит» — перемотка. 5 — вкладки «Конспект» и «Оглавление», клик по разделу — переход. Если останется время: вопрос-подсказка в чате, ответ с источником; или в Telegram у @lectiohackathon_bot написать вопрос со знаком «?» — ответ придёт со ссылками на моменты видео. Если что-то не грузится — показывать по скриншотам на этом слайде и в приложении.</a:t>
+              <a:t>60 секунд, живой показ строго по пунктам ТЗ, слева их порядок. 1 — в «Загрузить» → «Ссылка» вставить короткую ссылку youtu.be на лекцию, которая уже есть в библиотеке: Lectio узнаёт то же видео в любой форме ссылки и предлагает открыть готовую вместо повторной обработки — нажать «Открыть лекцию». Новую ссылку не импортировать: скачивание с YouTube зависит от сети, на защите оно может зависнуть. 2 — открыть готовую лекцию, вкладка «Расшифровка»: текст с таймкодами. 3 — поиск в шапке, запрос «как учиться с помощью нейросетей»: первой находится английская лекция; кликнуть результат — видео открывается на этой секунде. 4 — в плеере субтитры поверх видео; кликнуть реплику в «Сейчас говорит» — перемотка. 5 — вкладки «Конспект» и «Оглавление», клик по разделу — переход. Если останется время: страница «Термины» в шапке — энциклопедия по всем лекциям, ввести «катет» и кликнуть ссылку на момент; вопрос-подсказка в чате, ответ с источником; или в Telegram у @lectiohackathon_bot написать вопрос со знаком «?» — ответ придёт со ссылками на моменты видео. Если что-то не грузится — показывать по скриншотам на этом слайде и в приложении.</a:t>
             </a:r>
             <a:endParaRPr lang="en-US" dirty="0"/>
           </a:p>
@@ -1767,7 +1767,7 @@
           <a:p>
             <a:r>
               <a:rPr lang="en-US" dirty="0"/>
-              <a:t>Сразу после демо, коротко: всё, что вы только что видели, — это пять обязательных пунктов ТЗ.Все пять обязательных пунктов закрыты полностью. Из дополнительных фишек ТЗ сделаны поиск по курсу, чат по лекции, ключевые термины, импорт по ссылке и личный кабинет — организатор подтвердил, что он засчитывается. Офлайн-режим тоже есть: расшифровка, поиск и языковая модель работают локально, шрифты и формулы лежат в сборке фронта — сайт полностью работает без интернета. Интернет нужен только для импорта по ссылке с YouTube и для Telegram-бота. Сверх ТЗ: Telegram-бот, тест по лекции со статистикой для преподавателя, обсуждение, геймификация, хранилище видео в MinIO и проверка дублей — одно видео обрабатывается один раз.</a:t>
+              <a:t>Сразу после демо, коротко: всё, что вы только что видели, — это пять обязательных пунктов ТЗ.Все пять обязательных пунктов закрыты полностью. Из дополнительных фишек ТЗ сделаны поиск по курсу, чат по лекции, ключевые термины — у каждой лекции и общей энциклопедией по всем лекциям, — импорт по ссылке и личный кабинет — организатор подтвердил, что он засчитывается. Офлайн-режим тоже есть: расшифровка, поиск и языковая модель работают локально, шрифты и формулы лежат в сборке фронта — сайт полностью работает без интернета. Интернет нужен только для импорта по ссылке с YouTube и для Telegram-бота. Сверх ТЗ: Telegram-бот, тест по лекции со статистикой для преподавателя, обсуждение, геймификация, хранилище видео в MinIO и проверка дублей — одно видео обрабатывается один раз.</a:t>
             </a:r>
             <a:endParaRPr lang="en-US" dirty="0"/>
           </a:p>
@@ -2606,7 +2606,7 @@
                 <a:ea typeface="JetBrains Mono" pitchFamily="49" charset="-122"/>
                 <a:cs typeface="JetBrains Mono" pitchFamily="49" charset="-120"/>
               </a:rPr>
-              <a:t>КИБЕРРЫВОК 2026 · КЕЙС ФЦПТ СПБГУ</a:t>
+              <a:t>КИБЕРРЫВОК 2026 · КЕЙС ФЦПТ СПБГМТУ</a:t>
             </a:r>
             <a:endParaRPr lang="en-US" sz="1200" dirty="0"/>
           </a:p>
@@ -5045,7 +5045,74 @@
       </p:sp>
       <p:sp>
         <p:nvSpPr>
-          <p:cNvPr id="14" name="Text 10"/>
+          <p:cNvPr id="14" name="Shape 10"/>
+          <p:cNvSpPr/>
+          <p:nvPr/>
+        </p:nvSpPr>
+        <p:spPr>
+          <a:xfrm>
+            <a:off x="9436100" y="3681413"/>
+            <a:ext cx="1943100" cy="0"/>
+          </a:xfrm>
+          <a:prstGeom prst="line">
+            <a:avLst/>
+          </a:prstGeom>
+          <a:noFill/>
+          <a:ln w="12700">
+            <a:solidFill>
+              <a:srgbClr val="0F0F12"/>
+            </a:solidFill>
+            <a:prstDash val="solid"/>
+          </a:ln>
+        </p:spPr>
+      </p:sp>
+      <p:sp>
+        <p:nvSpPr>
+          <p:cNvPr id="15" name="Text 11"/>
+          <p:cNvSpPr/>
+          <p:nvPr/>
+        </p:nvSpPr>
+        <p:spPr>
+          <a:xfrm>
+            <a:off x="9436100" y="3789363"/>
+            <a:ext cx="2001393" cy="718641"/>
+          </a:xfrm>
+          <a:prstGeom prst="rect">
+            <a:avLst/>
+          </a:prstGeom>
+          <a:noFill/>
+          <a:ln/>
+        </p:spPr>
+        <p:txBody>
+          <a:bodyPr wrap="square" lIns="0" tIns="0" rIns="0" bIns="0" rtlCol="0" anchor="t">
+            <a:normAutofit/>
+          </a:bodyPr>
+          <a:lstStyle/>
+          <a:p>
+            <a:pPr algn="l" indent="0" marL="0">
+              <a:lnSpc>
+                <a:spcPts val="1820"/>
+              </a:lnSpc>
+              <a:buNone/>
+            </a:pPr>
+            <a:r>
+              <a:rPr lang="en-US" sz="1300" dirty="0">
+                <a:solidFill>
+                  <a:srgbClr val="0F0F12"/>
+                </a:solidFill>
+                <a:latin typeface="Golos Text" pitchFamily="34" charset="0"/>
+                <a:ea typeface="Golos Text" pitchFamily="34" charset="-122"/>
+                <a:cs typeface="Golos Text" pitchFamily="34" charset="-120"/>
+              </a:rPr>
+              <a:t>Энциклопедия терминов по всем лекциям</a:t>
+            </a:r>
+            <a:endParaRPr lang="en-US" sz="1300" dirty="0"/>
+          </a:p>
+        </p:txBody>
+      </p:sp>
+      <p:sp>
+        <p:nvSpPr>
+          <p:cNvPr id="16" name="Text 12"/>
           <p:cNvSpPr/>
           <p:nvPr/>
         </p:nvSpPr>
@@ -5089,7 +5156,7 @@
       </p:sp>
       <p:sp>
         <p:nvSpPr>
-          <p:cNvPr id="15" name="Text 11"/>
+          <p:cNvPr id="17" name="Text 13"/>
           <p:cNvSpPr/>
           <p:nvPr/>
         </p:nvSpPr>
@@ -10531,7 +10598,7 @@
         <p:spPr>
           <a:xfrm>
             <a:off x="8331200" y="1912541"/>
-            <a:ext cx="3048000" cy="3047802"/>
+            <a:ext cx="3048000" cy="3667522"/>
           </a:xfrm>
           <a:prstGeom prst="rect">
             <a:avLst/>
@@ -11039,7 +11106,85 @@
       </p:sp>
       <p:sp>
         <p:nvSpPr>
-          <p:cNvPr id="26" name="Text 24"/>
+          <p:cNvPr id="26" name="Shape 24"/>
+          <p:cNvSpPr/>
+          <p:nvPr/>
+        </p:nvSpPr>
+        <p:spPr>
+          <a:xfrm>
+            <a:off x="8534400" y="4852392"/>
+            <a:ext cx="2641600" cy="0"/>
+          </a:xfrm>
+          <a:prstGeom prst="line">
+            <a:avLst/>
+          </a:prstGeom>
+          <a:noFill/>
+          <a:ln w="12700">
+            <a:solidFill>
+              <a:srgbClr val="0F0F12"/>
+            </a:solidFill>
+            <a:prstDash val="solid"/>
+          </a:ln>
+        </p:spPr>
+      </p:sp>
+      <p:sp>
+        <p:nvSpPr>
+          <p:cNvPr id="27" name="Text 25"/>
+          <p:cNvSpPr/>
+          <p:nvPr/>
+        </p:nvSpPr>
+        <p:spPr>
+          <a:xfrm>
+            <a:off x="8534400" y="4947642"/>
+            <a:ext cx="2720848" cy="454620"/>
+          </a:xfrm>
+          <a:prstGeom prst="rect">
+            <a:avLst/>
+          </a:prstGeom>
+          <a:noFill/>
+          <a:ln/>
+        </p:spPr>
+        <p:txBody>
+          <a:bodyPr wrap="square" lIns="0" tIns="0" rIns="0" bIns="0" rtlCol="0" anchor="t">
+            <a:normAutofit/>
+          </a:bodyPr>
+          <a:lstStyle/>
+          <a:p>
+            <a:pPr algn="l" indent="0" marL="0">
+              <a:lnSpc>
+                <a:spcPts val="1690"/>
+              </a:lnSpc>
+              <a:buNone/>
+            </a:pPr>
+            <a:r>
+              <a:rPr lang="en-US" sz="1300" b="1" dirty="0">
+                <a:solidFill>
+                  <a:srgbClr val="0F0F12"/>
+                </a:solidFill>
+                <a:latin typeface="Golos Text" pitchFamily="34" charset="0"/>
+                <a:ea typeface="Golos Text" pitchFamily="34" charset="-122"/>
+                <a:cs typeface="Golos Text" pitchFamily="34" charset="-120"/>
+              </a:rPr>
+              <a:t>55 тестов</a:t>
+            </a:r>
+            <a:r>
+              <a:rPr lang="en-US" sz="1300" dirty="0">
+                <a:solidFill>
+                  <a:srgbClr val="0F0F12"/>
+                </a:solidFill>
+                <a:latin typeface="Golos Text" pitchFamily="34" charset="0"/>
+                <a:ea typeface="Golos Text" pitchFamily="34" charset="-122"/>
+                <a:cs typeface="Golos Text" pitchFamily="34" charset="-120"/>
+              </a:rPr>
+              <a:t> pytest на живых Postgres, Redis, MinIO</a:t>
+            </a:r>
+            <a:endParaRPr lang="en-US" sz="1300" dirty="0"/>
+          </a:p>
+        </p:txBody>
+      </p:sp>
+      <p:sp>
+        <p:nvSpPr>
+          <p:cNvPr id="28" name="Text 26"/>
           <p:cNvSpPr/>
           <p:nvPr/>
         </p:nvSpPr>
@@ -11083,7 +11228,7 @@
       </p:sp>
       <p:sp>
         <p:nvSpPr>
-          <p:cNvPr id="27" name="Text 25"/>
+          <p:cNvPr id="29" name="Text 27"/>
           <p:cNvSpPr/>
           <p:nvPr/>
         </p:nvSpPr>
@@ -13485,7 +13630,7 @@
         <p:spPr>
           <a:xfrm>
             <a:off x="8509000" y="3282652"/>
-            <a:ext cx="2066449" cy="274241"/>
+            <a:ext cx="2693789" cy="274241"/>
           </a:xfrm>
           <a:prstGeom prst="rect">
             <a:avLst/>
@@ -13514,7 +13659,7 @@
                 <a:ea typeface="Golos Text" pitchFamily="34" charset="-122"/>
                 <a:cs typeface="Golos Text" pitchFamily="34" charset="-120"/>
               </a:rPr>
-              <a:t>Ключевые термины</a:t>
+              <a:t>Термины и энциклопедия</a:t>
             </a:r>
             <a:endParaRPr lang="en-US" sz="1400" dirty="0"/>
           </a:p>

</xml_diff>

<commit_message>
fix(frontend): rename glossary, keep header on one row, course under lecture title
</commit_message>
<xml_diff>
--- a/Lectio — смысловой поиск по видеолекциям.pptx
+++ b/Lectio — смысловой поиск по видеолекциям.pptx
@@ -975,7 +975,7 @@
           <a:p>
             <a:r>
               <a:rPr lang="en-US" dirty="0"/>
-              <a:t>Конспект делает языковая модель: лекция обрабатывается по частям, потом части сводятся в общий конспект и оглавление — разделы и подразделы с таймкодами. Таймкоды мы «примагничиваем» к реальным началам фрагментов, чтобы клик по разделу попадал точно. Формулы рендерятся через KaTeX. Отдельно выделяются ключевые термины с определением и моментом, где их впервые объяснили. Из терминов всех лекций собирается общая энциклопедия: страница «Термины», где каждое понятие — с определениями из всех лекций, где его объясняли, и ссылкой на момент. Она обновляется сама, как только у лекции появляется конспект. Если модель недоступна, лекция всё равно ищется и смотрится — конспект best effort.</a:t>
+              <a:t>Конспект делает языковая модель: лекция обрабатывается по частям, потом части сводятся в общий конспект и оглавление — разделы и подразделы с таймкодами. Таймкоды мы «примагничиваем» к реальным началам фрагментов, чтобы клик по разделу попадал точно. Формулы рендерятся через KaTeX. Отдельно выделяются ключевые термины с определением и моментом, где их впервые объяснили. Из терминов всех лекций собирается общий глоссарий: страница «Глоссарий», где каждое понятие — с определениями из всех лекций, где его объясняли, и ссылкой на момент. Она обновляется сама, как только у лекции появляется конспект. Если модель недоступна, лекция всё равно ищется и смотрится — конспект best effort.</a:t>
             </a:r>
             <a:endParaRPr lang="en-US" dirty="0"/>
           </a:p>
@@ -1679,7 +1679,7 @@
           <a:p>
             <a:r>
               <a:rPr lang="en-US" dirty="0"/>
-              <a:t>60 секунд, живой показ строго по пунктам ТЗ, слева их порядок. 1 — в «Загрузить» → «Ссылка» вставить короткую ссылку youtu.be на лекцию, которая уже есть в библиотеке: Lectio узнаёт то же видео в любой форме ссылки и предлагает открыть готовую вместо повторной обработки — нажать «Открыть лекцию». Новую ссылку не импортировать: скачивание с YouTube зависит от сети, на защите оно может зависнуть. 2 — открыть готовую лекцию, вкладка «Расшифровка»: текст с таймкодами. 3 — поиск в шапке, запрос «как учиться с помощью нейросетей»: первой находится английская лекция; кликнуть результат — видео открывается на этой секунде. 4 — в плеере субтитры поверх видео; кликнуть реплику в «Сейчас говорит» — перемотка. 5 — вкладки «Конспект» и «Оглавление», клик по разделу — переход. Если останется время: страница «Термины» в шапке — энциклопедия по всем лекциям, ввести «катет» и кликнуть ссылку на момент; вопрос-подсказка в чате, ответ с источником; или в Telegram у @lectiohackathon_bot написать вопрос со знаком «?» — ответ придёт со ссылками на моменты видео. Если что-то не грузится — показывать по скриншотам на этом слайде и в приложении.</a:t>
+              <a:t>60 секунд, живой показ строго по пунктам ТЗ, слева их порядок. 1 — в «Загрузить» → «Ссылка» вставить короткую ссылку youtu.be на лекцию, которая уже есть в библиотеке: Lectio узнаёт то же видео в любой форме ссылки и предлагает открыть готовую вместо повторной обработки — нажать «Открыть лекцию». Новую ссылку не импортировать: скачивание с YouTube зависит от сети, на защите оно может зависнуть. 2 — открыть готовую лекцию, вкладка «Расшифровка»: текст с таймкодами. 3 — поиск в шапке, запрос «как учиться с помощью нейросетей»: первой находится английская лекция; кликнуть результат — видео открывается на этой секунде. 4 — в плеере субтитры поверх видео; кликнуть реплику в «Сейчас говорит» — перемотка. 5 — вкладки «Конспект» и «Оглавление», клик по разделу — переход. Если останется время: страница «Глоссарий» в шапке — термины всех лекций, ввести «катет» и кликнуть ссылку на момент; вопрос-подсказка в чате, ответ с источником; или в Telegram у @lectiohackathon_bot написать вопрос со знаком «?» — ответ придёт со ссылками на моменты видео. Если что-то не грузится — показывать по скриншотам на этом слайде и в приложении.</a:t>
             </a:r>
             <a:endParaRPr lang="en-US" dirty="0"/>
           </a:p>
@@ -1767,7 +1767,7 @@
           <a:p>
             <a:r>
               <a:rPr lang="en-US" dirty="0"/>
-              <a:t>Сразу после демо, коротко: всё, что вы только что видели, — это пять обязательных пунктов ТЗ.Все пять обязательных пунктов закрыты полностью. Из дополнительных фишек ТЗ сделаны поиск по курсу, чат по лекции, ключевые термины — у каждой лекции и общей энциклопедией по всем лекциям, — импорт по ссылке и личный кабинет — организатор подтвердил, что он засчитывается. Офлайн-режим тоже есть: расшифровка, поиск и языковая модель работают локально, шрифты и формулы лежат в сборке фронта — сайт полностью работает без интернета. Интернет нужен только для импорта по ссылке с YouTube и для Telegram-бота. Сверх ТЗ: Telegram-бот, тест по лекции со статистикой для преподавателя, обсуждение, геймификация, хранилище видео в MinIO и проверка дублей — одно видео обрабатывается один раз.</a:t>
+              <a:t>Сразу после демо, коротко: всё, что вы только что видели, — это пять обязательных пунктов ТЗ.Все пять обязательных пунктов закрыты полностью. Из дополнительных фишек ТЗ сделаны поиск по курсу, чат по лекции, ключевые термины — у каждой лекции и общим глоссарием по всем лекциям, — импорт по ссылке и личный кабинет — организатор подтвердил, что он засчитывается. Офлайн-режим тоже есть: расшифровка, поиск и языковая модель работают локально, шрифты и формулы лежат в сборке фронта — сайт полностью работает без интернета. Интернет нужен только для импорта по ссылке с YouTube и для Telegram-бота. Сверх ТЗ: Telegram-бот, тест по лекции со статистикой для преподавателя, обсуждение, геймификация, хранилище видео в MinIO и проверка дублей — одно видео обрабатывается один раз.</a:t>
             </a:r>
             <a:endParaRPr lang="en-US" dirty="0"/>
           </a:p>
@@ -3582,7 +3582,7 @@
         </p:nvPicPr>
         <p:blipFill>
           <a:blip r:embed="rId1"/>
-          <a:srcRect l="0" r="0" t="131" b="131"/>
+          <a:srcRect l="0" r="0" t="168" b="168"/>
           <a:stretch/>
         </p:blipFill>
         <p:spPr>
@@ -5075,7 +5075,7 @@
         <p:spPr>
           <a:xfrm>
             <a:off x="9436100" y="3789363"/>
-            <a:ext cx="2001393" cy="718641"/>
+            <a:ext cx="2001393" cy="487561"/>
           </a:xfrm>
           <a:prstGeom prst="rect">
             <a:avLst/>
@@ -5104,7 +5104,7 @@
                 <a:ea typeface="Golos Text" pitchFamily="34" charset="-122"/>
                 <a:cs typeface="Golos Text" pitchFamily="34" charset="-120"/>
               </a:rPr>
-              <a:t>Энциклопедия терминов по всем лекциям</a:t>
+              <a:t>Глоссарий по всем лекциям</a:t>
             </a:r>
             <a:endParaRPr lang="en-US" sz="1300" dirty="0"/>
           </a:p>
@@ -12091,7 +12091,7 @@
         </p:nvPicPr>
         <p:blipFill>
           <a:blip r:embed="rId1"/>
-          <a:srcRect l="0" r="0" t="0" b="1086"/>
+          <a:srcRect l="0" r="0" t="0" b="1159"/>
           <a:stretch/>
         </p:blipFill>
         <p:spPr>
@@ -13630,7 +13630,7 @@
         <p:spPr>
           <a:xfrm>
             <a:off x="8509000" y="3282652"/>
-            <a:ext cx="2693789" cy="274241"/>
+            <a:ext cx="2261711" cy="274241"/>
           </a:xfrm>
           <a:prstGeom prst="rect">
             <a:avLst/>
@@ -13659,7 +13659,7 @@
                 <a:ea typeface="Golos Text" pitchFamily="34" charset="-122"/>
                 <a:cs typeface="Golos Text" pitchFamily="34" charset="-120"/>
               </a:rPr>
-              <a:t>Термины и энциклопедия</a:t>
+              <a:t>Термины и глоссарий</a:t>
             </a:r>
             <a:endParaRPr lang="en-US" sz="1400" dirty="0"/>
           </a:p>

</xml_diff>